<commit_message>
Update Character Controller Architecture.pptx
</commit_message>
<xml_diff>
--- a/Documentation/Character Controller Architecture.pptx
+++ b/Documentation/Character Controller Architecture.pptx
@@ -4183,55 +4183,6 @@
             <a:r>
               <a:rPr lang="en-GB" dirty="0"/>
               <a:t>on the CC.</a:t>
-            </a:r>
-          </a:p>
-        </p:txBody>
-      </p:sp>
-      <p:sp>
-        <p:nvSpPr>
-          <p:cNvPr id="31" name="Rectangle: Rounded Corners 30">
-            <a:extLst>
-              <a:ext uri="{FF2B5EF4-FFF2-40B4-BE49-F238E27FC236}">
-                <a16:creationId xmlns:a16="http://schemas.microsoft.com/office/drawing/2014/main" id="{3B7176A7-3B3E-57E7-F6B8-01749F85BC96}"/>
-              </a:ext>
-            </a:extLst>
-          </p:cNvPr>
-          <p:cNvSpPr/>
-          <p:nvPr/>
-        </p:nvSpPr>
-        <p:spPr>
-          <a:xfrm>
-            <a:off x="8966681" y="3823889"/>
-            <a:ext cx="1586094" cy="1153569"/>
-          </a:xfrm>
-          <a:prstGeom prst="roundRect">
-            <a:avLst/>
-          </a:prstGeom>
-        </p:spPr>
-        <p:style>
-          <a:lnRef idx="2">
-            <a:schemeClr val="accent1">
-              <a:shade val="15000"/>
-            </a:schemeClr>
-          </a:lnRef>
-          <a:fillRef idx="1">
-            <a:schemeClr val="accent1"/>
-          </a:fillRef>
-          <a:effectRef idx="0">
-            <a:schemeClr val="accent1"/>
-          </a:effectRef>
-          <a:fontRef idx="minor">
-            <a:schemeClr val="lt1"/>
-          </a:fontRef>
-        </p:style>
-        <p:txBody>
-          <a:bodyPr rtlCol="0" anchor="ctr"/>
-          <a:lstStyle/>
-          <a:p>
-            <a:pPr algn="ctr"/>
-            <a:r>
-              <a:rPr lang="en-GB" dirty="0"/>
-              <a:t>Enemy Controller</a:t>
             </a:r>
           </a:p>
         </p:txBody>

</xml_diff>